<commit_message>
Polish Arctic map and source links
Co-authored-by: vaslarinmelnikova-hash <vaslarinmelnikova-hash@users.noreply.github.com>
</commit_message>
<xml_diff>
--- a/Militarisation_de_l_Arctique.pptx
+++ b/Militarisation_de_l_Arctique.pptx
@@ -8097,7 +8097,9 @@
       </p:sp>
       <p:sp>
         <p:nvSpPr>
-          <p:cNvPr id="8" name="TextBox 7"/>
+          <p:cNvPr id="8" name="TextBox 7">
+            <a:hlinkClick r:id="rId2"/>
+          </p:cNvPr>
           <p:cNvSpPr txBox="1"/>
           <p:nvPr/>
         </p:nvSpPr>
@@ -8128,7 +8130,6 @@
                   <a:srgbClr val="F4F8FB"/>
                 </a:solidFill>
                 <a:latin typeface="Inter"/>
-                <a:hlinkClick r:id="rId2"/>
               </a:rPr>
               <a:t>OTAN — Arctic Sentry, 11 fév. 2026</a:t>
             </a:r>
@@ -8137,7 +8138,9 @@
       </p:sp>
       <p:sp>
         <p:nvSpPr>
-          <p:cNvPr id="9" name="TextBox 8"/>
+          <p:cNvPr id="9" name="TextBox 8">
+            <a:hlinkClick r:id="rId2"/>
+          </p:cNvPr>
           <p:cNvSpPr txBox="1"/>
           <p:nvPr/>
         </p:nvSpPr>
@@ -8168,7 +8171,6 @@
                   <a:srgbClr val="7895A8"/>
                 </a:solidFill>
                 <a:latin typeface="Inter"/>
-                <a:hlinkClick r:id="rId2"/>
               </a:rPr>
               <a:t>https://www.nato.int/en/news-and-events/articles/news/2026/02/11/nato-secretary-general-outlines-new-activity-arctic-sentry-ahead-of-defence-ministers-meeting</a:t>
             </a:r>
@@ -8216,7 +8218,9 @@
       </p:sp>
       <p:sp>
         <p:nvSpPr>
-          <p:cNvPr id="11" name="TextBox 10"/>
+          <p:cNvPr id="11" name="TextBox 10">
+            <a:hlinkClick r:id="rId3"/>
+          </p:cNvPr>
           <p:cNvSpPr txBox="1"/>
           <p:nvPr/>
         </p:nvSpPr>
@@ -8247,7 +8251,6 @@
                   <a:srgbClr val="F4F8FB"/>
                 </a:solidFill>
                 <a:latin typeface="Inter"/>
-                <a:hlinkClick r:id="rId3"/>
               </a:rPr>
               <a:t>OTAN — sécurité du Grand Nord, 8 juin 2026</a:t>
             </a:r>
@@ -8256,7 +8259,9 @@
       </p:sp>
       <p:sp>
         <p:nvSpPr>
-          <p:cNvPr id="12" name="TextBox 11"/>
+          <p:cNvPr id="12" name="TextBox 11">
+            <a:hlinkClick r:id="rId3"/>
+          </p:cNvPr>
           <p:cNvSpPr txBox="1"/>
           <p:nvPr/>
         </p:nvSpPr>
@@ -8287,7 +8292,6 @@
                   <a:srgbClr val="7895A8"/>
                 </a:solidFill>
                 <a:latin typeface="Inter"/>
-                <a:hlinkClick r:id="rId3"/>
               </a:rPr>
               <a:t>https://www.nato.int/en/news-and-events/articles/news/2026/06/08/nato-enhances-security-in-the-arctic-and-high-north</a:t>
             </a:r>
@@ -8335,7 +8339,9 @@
       </p:sp>
       <p:sp>
         <p:nvSpPr>
-          <p:cNvPr id="14" name="TextBox 13"/>
+          <p:cNvPr id="14" name="TextBox 13">
+            <a:hlinkClick r:id="rId4"/>
+          </p:cNvPr>
           <p:cNvSpPr txBox="1"/>
           <p:nvPr/>
         </p:nvSpPr>
@@ -8366,7 +8372,6 @@
                   <a:srgbClr val="F4F8FB"/>
                 </a:solidFill>
                 <a:latin typeface="Inter"/>
-                <a:hlinkClick r:id="rId4"/>
               </a:rPr>
               <a:t>JFC Norfolk — intégration des Alliés nordiques, 2025</a:t>
             </a:r>
@@ -8375,7 +8380,9 @@
       </p:sp>
       <p:sp>
         <p:nvSpPr>
-          <p:cNvPr id="15" name="TextBox 14"/>
+          <p:cNvPr id="15" name="TextBox 14">
+            <a:hlinkClick r:id="rId4"/>
+          </p:cNvPr>
           <p:cNvSpPr txBox="1"/>
           <p:nvPr/>
         </p:nvSpPr>
@@ -8406,7 +8413,6 @@
                   <a:srgbClr val="7895A8"/>
                 </a:solidFill>
                 <a:latin typeface="Inter"/>
-                <a:hlinkClick r:id="rId4"/>
               </a:rPr>
               <a:t>https://jfcnorfolk.nato.int/activity/joint-force-command-norfolk-welcomes-nordic-allies-to-its-area-of-responsibility</a:t>
             </a:r>
@@ -8454,7 +8460,9 @@
       </p:sp>
       <p:sp>
         <p:nvSpPr>
-          <p:cNvPr id="17" name="TextBox 16"/>
+          <p:cNvPr id="17" name="TextBox 16">
+            <a:hlinkClick r:id="rId5"/>
+          </p:cNvPr>
           <p:cNvSpPr txBox="1"/>
           <p:nvPr/>
         </p:nvSpPr>
@@ -8485,7 +8493,6 @@
                   <a:srgbClr val="F4F8FB"/>
                 </a:solidFill>
                 <a:latin typeface="Inter"/>
-                <a:hlinkClick r:id="rId5"/>
               </a:rPr>
               <a:t>NSIDC — minimum de banquise 2025</a:t>
             </a:r>
@@ -8494,7 +8501,9 @@
       </p:sp>
       <p:sp>
         <p:nvSpPr>
-          <p:cNvPr id="18" name="TextBox 17"/>
+          <p:cNvPr id="18" name="TextBox 17">
+            <a:hlinkClick r:id="rId5"/>
+          </p:cNvPr>
           <p:cNvSpPr txBox="1"/>
           <p:nvPr/>
         </p:nvSpPr>
@@ -8525,7 +8534,6 @@
                   <a:srgbClr val="7895A8"/>
                 </a:solidFill>
                 <a:latin typeface="Inter"/>
-                <a:hlinkClick r:id="rId5"/>
               </a:rPr>
               <a:t>https://nsidc.org/sea-ice-today/analyses/2025-arctic-sea-ice-minimum-squeezes-ten-lowest-minimums</a:t>
             </a:r>
@@ -8573,7 +8581,9 @@
       </p:sp>
       <p:sp>
         <p:nvSpPr>
-          <p:cNvPr id="20" name="TextBox 19"/>
+          <p:cNvPr id="20" name="TextBox 19">
+            <a:hlinkClick r:id="rId6"/>
+          </p:cNvPr>
           <p:cNvSpPr txBox="1"/>
           <p:nvPr/>
         </p:nvSpPr>
@@ -8604,7 +8614,6 @@
                   <a:srgbClr val="F4F8FB"/>
                 </a:solidFill>
                 <a:latin typeface="Inter"/>
-                <a:hlinkClick r:id="rId6"/>
               </a:rPr>
               <a:t>Conseil de l’Arctique — mandat et organisation</a:t>
             </a:r>
@@ -8613,7 +8622,9 @@
       </p:sp>
       <p:sp>
         <p:nvSpPr>
-          <p:cNvPr id="21" name="TextBox 20"/>
+          <p:cNvPr id="21" name="TextBox 20">
+            <a:hlinkClick r:id="rId6"/>
+          </p:cNvPr>
           <p:cNvSpPr txBox="1"/>
           <p:nvPr/>
         </p:nvSpPr>
@@ -8644,7 +8655,6 @@
                   <a:srgbClr val="7895A8"/>
                 </a:solidFill>
                 <a:latin typeface="Inter"/>
-                <a:hlinkClick r:id="rId6"/>
               </a:rPr>
               <a:t>https://arctic-council.org/about/</a:t>
             </a:r>
@@ -8692,7 +8702,9 @@
       </p:sp>
       <p:sp>
         <p:nvSpPr>
-          <p:cNvPr id="23" name="TextBox 22"/>
+          <p:cNvPr id="23" name="TextBox 22">
+            <a:hlinkClick r:id="rId7"/>
+          </p:cNvPr>
           <p:cNvSpPr txBox="1"/>
           <p:nvPr/>
         </p:nvSpPr>
@@ -8723,7 +8735,6 @@
                   <a:srgbClr val="F4F8FB"/>
                 </a:solidFill>
                 <a:latin typeface="Inter"/>
-                <a:hlinkClick r:id="rId7"/>
               </a:rPr>
               <a:t>Conseil de l’Arctique — mise à jour 2026</a:t>
             </a:r>
@@ -8732,7 +8743,9 @@
       </p:sp>
       <p:sp>
         <p:nvSpPr>
-          <p:cNvPr id="24" name="TextBox 23"/>
+          <p:cNvPr id="24" name="TextBox 23">
+            <a:hlinkClick r:id="rId7"/>
+          </p:cNvPr>
           <p:cNvSpPr txBox="1"/>
           <p:nvPr/>
         </p:nvSpPr>
@@ -8763,7 +8776,6 @@
                   <a:srgbClr val="7895A8"/>
                 </a:solidFill>
                 <a:latin typeface="Inter"/>
-                <a:hlinkClick r:id="rId7"/>
               </a:rPr>
               <a:t>https://arctic-council.org/news/2026-arctic-council-update/</a:t>
             </a:r>
@@ -8811,7 +8823,9 @@
       </p:sp>
       <p:sp>
         <p:nvSpPr>
-          <p:cNvPr id="26" name="TextBox 25"/>
+          <p:cNvPr id="26" name="TextBox 25">
+            <a:hlinkClick r:id="rId8"/>
+          </p:cNvPr>
           <p:cNvSpPr txBox="1"/>
           <p:nvPr/>
         </p:nvSpPr>
@@ -8842,7 +8856,6 @@
                   <a:srgbClr val="F4F8FB"/>
                 </a:solidFill>
                 <a:latin typeface="Inter"/>
-                <a:hlinkClick r:id="rId8"/>
               </a:rPr>
               <a:t>CSIS — The Ice Curtain: Kola Peninsula</a:t>
             </a:r>
@@ -8851,7 +8864,9 @@
       </p:sp>
       <p:sp>
         <p:nvSpPr>
-          <p:cNvPr id="27" name="TextBox 26"/>
+          <p:cNvPr id="27" name="TextBox 26">
+            <a:hlinkClick r:id="rId8"/>
+          </p:cNvPr>
           <p:cNvSpPr txBox="1"/>
           <p:nvPr/>
         </p:nvSpPr>
@@ -8882,7 +8897,6 @@
                   <a:srgbClr val="7895A8"/>
                 </a:solidFill>
                 <a:latin typeface="Inter"/>
-                <a:hlinkClick r:id="rId8"/>
               </a:rPr>
               <a:t>https://www.csis.org/analysis/ice-curtain-modernization-kola-peninsula</a:t>
             </a:r>
@@ -8930,7 +8944,9 @@
       </p:sp>
       <p:sp>
         <p:nvSpPr>
-          <p:cNvPr id="29" name="TextBox 28"/>
+          <p:cNvPr id="29" name="TextBox 28">
+            <a:hlinkClick r:id="rId9"/>
+          </p:cNvPr>
           <p:cNvSpPr txBox="1"/>
           <p:nvPr/>
         </p:nvSpPr>
@@ -8961,7 +8977,6 @@
                   <a:srgbClr val="F4F8FB"/>
                 </a:solidFill>
                 <a:latin typeface="Inter"/>
-                <a:hlinkClick r:id="rId9"/>
               </a:rPr>
               <a:t>DoD — 2024 Arctic Strategy</a:t>
             </a:r>
@@ -8970,7 +8985,9 @@
       </p:sp>
       <p:sp>
         <p:nvSpPr>
-          <p:cNvPr id="30" name="TextBox 29"/>
+          <p:cNvPr id="30" name="TextBox 29">
+            <a:hlinkClick r:id="rId9"/>
+          </p:cNvPr>
           <p:cNvSpPr txBox="1"/>
           <p:nvPr/>
         </p:nvSpPr>
@@ -9001,7 +9018,6 @@
                   <a:srgbClr val="7895A8"/>
                 </a:solidFill>
                 <a:latin typeface="Inter"/>
-                <a:hlinkClick r:id="rId9"/>
               </a:rPr>
               <a:t>https://media.defense.gov/2024/Jul/22/2003507411/-1/-1/0/DOD-ARCTIC-STRATEGY-2024.PDF</a:t>
             </a:r>

</xml_diff>